<commit_message>
Sync M25 v1.1: Modulinhalt + Teilnehmerunterlagen aktualisiert
</commit_message>
<xml_diff>
--- a/protected-downloads/praesentation/M25.pptx
+++ b/protected-downloads/praesentation/M25.pptx
@@ -670,6 +670,11 @@
           <a:p>
             <a:r>
               <a:t>Format: Runde im Plenum, jeder ein Satz, kein Kommentar. Tempo halten.</a:t>
+            </a:r>
+          </a:p>
+          <a:p>
+            <a:r>
+              <a:t>Nennt jemand ein Gespräch mit der Teamleitung als Hebel, kurz bestätigen ("Genau richtig – das ist Ihr erster Schritt.") und weitergeben. Berufseinsteiger sind unsicher, ob ein Vorbereitungsschritt "zählt".</a:t>
             </a:r>
           </a:p>
           <a:p>
@@ -4804,7 +4809,7 @@
                 </a:solidFill>
                 <a:latin typeface="Arial"/>
               </a:rPr>
-              <a:t>v1.0</a:t>
+              <a:t>v1.1</a:t>
             </a:r>
           </a:p>
         </p:txBody>
@@ -8298,6 +8303,25 @@
                 <a:latin typeface="Arial"/>
               </a:rPr>
               <a:t>▸  Jeder nennt einen Satz – Hebel + konkreter Schritt.</a:t>
+            </a:r>
+          </a:p>
+          <a:p>
+            <a:pPr marL="190500" indent="-190500">
+              <a:spcBef>
+                <a:spcPts val="400"/>
+              </a:spcBef>
+              <a:spcAft>
+                <a:spcPts val="200"/>
+              </a:spcAft>
+            </a:pPr>
+            <a:r>
+              <a:rPr sz="1300">
+                <a:solidFill>
+                  <a:srgbClr val="3D5466"/>
+                </a:solidFill>
+                <a:latin typeface="Arial"/>
+              </a:rPr>
+              <a:t>▸  Ihr Hebel kann auch ein Gespräch oder eine Vereinbarung sein.</a:t>
             </a:r>
           </a:p>
           <a:p>

</xml_diff>